<commit_message>
fix(documents): deterministic fixtures; tabs, breaks and paragraph separators
Co-Authored-By: Claude Fable 5.1 <noreply@anthropic.com>
Claude-Session: https://claude.ai/code/session_01NC7DaU2NnuShutQWthiRhF
</commit_message>
<xml_diff>
--- a/tests/fixtures/docs/sample.pptx
+++ b/tests/fixtures/docs/sample.pptx
@@ -13,6 +13,14 @@
               <a:t>300 participants</a:t>
             </a:r>
           </a:p>
+          <a:p>
+            <a:r>
+              <a:t>Across two </a:t>
+            </a:r>
+            <a:r>
+              <a:t>study sites.</a:t>
+            </a:r>
+          </a:p>
         </p:txBody>
       </p:sp>
     </p:spTree>

</xml_diff>